<commit_message>
Update Jupyter Notebook and presentation
</commit_message>
<xml_diff>
--- a/docs/LLM presentation.pptx
+++ b/docs/LLM presentation.pptx
@@ -234,7 +234,7 @@
           <a:p>
             <a:fld id="{755C9F4E-E920-4D44-949A-A478FAE3130F}" type="datetimeFigureOut">
               <a:rPr lang="en-US" smtClean="0"/>
-              <a:t>7/6/25</a:t>
+              <a:t>7/8/25</a:t>
             </a:fld>
             <a:endParaRPr lang="en-US"/>
           </a:p>
@@ -648,7 +648,7 @@
           <a:p>
             <a:fld id="{F1275B78-02F6-4B47-B918-CE7AA020551C}" type="datetimeFigureOut">
               <a:rPr lang="en-US" smtClean="0"/>
-              <a:t>7/6/25</a:t>
+              <a:t>7/8/25</a:t>
             </a:fld>
             <a:endParaRPr lang="en-US"/>
           </a:p>
@@ -846,7 +846,7 @@
           <a:p>
             <a:fld id="{F1275B78-02F6-4B47-B918-CE7AA020551C}" type="datetimeFigureOut">
               <a:rPr lang="en-US" smtClean="0"/>
-              <a:t>7/6/25</a:t>
+              <a:t>7/8/25</a:t>
             </a:fld>
             <a:endParaRPr lang="en-US"/>
           </a:p>
@@ -1054,7 +1054,7 @@
           <a:p>
             <a:fld id="{F1275B78-02F6-4B47-B918-CE7AA020551C}" type="datetimeFigureOut">
               <a:rPr lang="en-US" smtClean="0"/>
-              <a:t>7/6/25</a:t>
+              <a:t>7/8/25</a:t>
             </a:fld>
             <a:endParaRPr lang="en-US"/>
           </a:p>
@@ -1252,7 +1252,7 @@
           <a:p>
             <a:fld id="{F1275B78-02F6-4B47-B918-CE7AA020551C}" type="datetimeFigureOut">
               <a:rPr lang="en-US" smtClean="0"/>
-              <a:t>7/6/25</a:t>
+              <a:t>7/8/25</a:t>
             </a:fld>
             <a:endParaRPr lang="en-US"/>
           </a:p>
@@ -1527,7 +1527,7 @@
           <a:p>
             <a:fld id="{F1275B78-02F6-4B47-B918-CE7AA020551C}" type="datetimeFigureOut">
               <a:rPr lang="en-US" smtClean="0"/>
-              <a:t>7/6/25</a:t>
+              <a:t>7/8/25</a:t>
             </a:fld>
             <a:endParaRPr lang="en-US"/>
           </a:p>
@@ -1792,7 +1792,7 @@
           <a:p>
             <a:fld id="{F1275B78-02F6-4B47-B918-CE7AA020551C}" type="datetimeFigureOut">
               <a:rPr lang="en-US" smtClean="0"/>
-              <a:t>7/6/25</a:t>
+              <a:t>7/8/25</a:t>
             </a:fld>
             <a:endParaRPr lang="en-US"/>
           </a:p>
@@ -2204,7 +2204,7 @@
           <a:p>
             <a:fld id="{F1275B78-02F6-4B47-B918-CE7AA020551C}" type="datetimeFigureOut">
               <a:rPr lang="en-US" smtClean="0"/>
-              <a:t>7/6/25</a:t>
+              <a:t>7/8/25</a:t>
             </a:fld>
             <a:endParaRPr lang="en-US"/>
           </a:p>
@@ -2345,7 +2345,7 @@
           <a:p>
             <a:fld id="{F1275B78-02F6-4B47-B918-CE7AA020551C}" type="datetimeFigureOut">
               <a:rPr lang="en-US" smtClean="0"/>
-              <a:t>7/6/25</a:t>
+              <a:t>7/8/25</a:t>
             </a:fld>
             <a:endParaRPr lang="en-US"/>
           </a:p>
@@ -2458,7 +2458,7 @@
           <a:p>
             <a:fld id="{F1275B78-02F6-4B47-B918-CE7AA020551C}" type="datetimeFigureOut">
               <a:rPr lang="en-US" smtClean="0"/>
-              <a:t>7/6/25</a:t>
+              <a:t>7/8/25</a:t>
             </a:fld>
             <a:endParaRPr lang="en-US"/>
           </a:p>
@@ -2769,7 +2769,7 @@
           <a:p>
             <a:fld id="{F1275B78-02F6-4B47-B918-CE7AA020551C}" type="datetimeFigureOut">
               <a:rPr lang="en-US" smtClean="0"/>
-              <a:t>7/6/25</a:t>
+              <a:t>7/8/25</a:t>
             </a:fld>
             <a:endParaRPr lang="en-US"/>
           </a:p>
@@ -3057,7 +3057,7 @@
           <a:p>
             <a:fld id="{F1275B78-02F6-4B47-B918-CE7AA020551C}" type="datetimeFigureOut">
               <a:rPr lang="en-US" smtClean="0"/>
-              <a:t>7/6/25</a:t>
+              <a:t>7/8/25</a:t>
             </a:fld>
             <a:endParaRPr lang="en-US"/>
           </a:p>
@@ -3298,7 +3298,7 @@
           <a:p>
             <a:fld id="{F1275B78-02F6-4B47-B918-CE7AA020551C}" type="datetimeFigureOut">
               <a:rPr lang="en-US" smtClean="0"/>
-              <a:t>7/6/25</a:t>
+              <a:t>7/8/25</a:t>
             </a:fld>
             <a:endParaRPr lang="en-US"/>
           </a:p>
@@ -3731,13 +3731,20 @@
             <p:ph type="ctrTitle"/>
           </p:nvPr>
         </p:nvSpPr>
-        <p:spPr/>
-        <p:txBody>
-          <a:bodyPr/>
+        <p:spPr>
+          <a:xfrm>
+            <a:off x="55037" y="1041400"/>
+            <a:ext cx="9144000" cy="2387600"/>
+          </a:xfrm>
+        </p:spPr>
+        <p:txBody>
+          <a:bodyPr>
+            <a:normAutofit/>
+          </a:bodyPr>
           <a:lstStyle/>
           <a:p>
             <a:r>
-              <a:rPr lang="en-US" dirty="0"/>
+              <a:rPr lang="en-US" sz="6600" dirty="0"/>
               <a:t>Introduction to RAG</a:t>
             </a:r>
           </a:p>
@@ -3759,26 +3766,138 @@
             <p:ph type="subTitle" idx="1"/>
           </p:nvPr>
         </p:nvSpPr>
-        <p:spPr/>
+        <p:spPr>
+          <a:xfrm>
+            <a:off x="-2246812" y="3429000"/>
+            <a:ext cx="9144000" cy="1655762"/>
+          </a:xfrm>
+        </p:spPr>
         <p:txBody>
           <a:bodyPr/>
           <a:lstStyle/>
           <a:p>
             <a:r>
               <a:rPr lang="en-US" dirty="0"/>
-              <a:t>By Carlo Teufel </a:t>
-            </a:r>
+              <a:t>By Carlo Teufel</a:t>
+            </a:r>
+            <a:endParaRPr lang="en-US" i="1" dirty="0"/>
+          </a:p>
+        </p:txBody>
+      </p:sp>
+      <p:pic>
+        <p:nvPicPr>
+          <p:cNvPr id="4" name="Picture 2" descr="Carlo Teufel">
+            <a:extLst>
+              <a:ext uri="{FF2B5EF4-FFF2-40B4-BE49-F238E27FC236}">
+                <a16:creationId xmlns:a16="http://schemas.microsoft.com/office/drawing/2014/main" id="{D2C39F23-3028-9105-AC88-7A8833B3690E}"/>
+              </a:ext>
+            </a:extLst>
+          </p:cNvPr>
+          <p:cNvPicPr>
+            <a:picLocks noChangeAspect="1" noChangeArrowheads="1"/>
+          </p:cNvPicPr>
+          <p:nvPr/>
+        </p:nvPicPr>
+        <p:blipFill>
+          <a:blip r:embed="rId2">
+            <a:extLst>
+              <a:ext uri="{28A0092B-C50C-407E-A947-70E740481C1C}">
+                <a14:useLocalDpi xmlns:a14="http://schemas.microsoft.com/office/drawing/2010/main" val="0"/>
+              </a:ext>
+            </a:extLst>
+          </a:blip>
+          <a:srcRect/>
+          <a:stretch>
+            <a:fillRect/>
+          </a:stretch>
+        </p:blipFill>
+        <p:spPr bwMode="auto">
+          <a:xfrm>
+            <a:off x="8872466" y="1828133"/>
+            <a:ext cx="2334054" cy="2334054"/>
+          </a:xfrm>
+          <a:prstGeom prst="rect">
+            <a:avLst/>
+          </a:prstGeom>
+          <a:noFill/>
+          <a:effectLst>
+            <a:softEdge rad="63500"/>
+          </a:effectLst>
+          <a:extLst>
+            <a:ext uri="{909E8E84-426E-40DD-AFC4-6F175D3DCCD1}">
+              <a14:hiddenFill xmlns:a14="http://schemas.microsoft.com/office/drawing/2010/main">
+                <a:solidFill>
+                  <a:srgbClr val="FFFFFF"/>
+                </a:solidFill>
+              </a14:hiddenFill>
+            </a:ext>
+          </a:extLst>
+        </p:spPr>
+      </p:pic>
+      <p:sp>
+        <p:nvSpPr>
+          <p:cNvPr id="6" name="TextBox 5">
+            <a:extLst>
+              <a:ext uri="{FF2B5EF4-FFF2-40B4-BE49-F238E27FC236}">
+                <a16:creationId xmlns:a16="http://schemas.microsoft.com/office/drawing/2014/main" id="{DA0A6308-B1CB-50C7-941D-E2DDFD0DF203}"/>
+              </a:ext>
+            </a:extLst>
+          </p:cNvPr>
+          <p:cNvSpPr txBox="1"/>
+          <p:nvPr/>
+        </p:nvSpPr>
+        <p:spPr>
+          <a:xfrm>
+            <a:off x="8872466" y="4187803"/>
+            <a:ext cx="6104238" cy="1200329"/>
+          </a:xfrm>
+          <a:prstGeom prst="rect">
+            <a:avLst/>
+          </a:prstGeom>
+          <a:noFill/>
+        </p:spPr>
+        <p:txBody>
+          <a:bodyPr wrap="square">
+            <a:spAutoFit/>
+          </a:bodyPr>
+          <a:lstStyle/>
+          <a:p>
+            <a:r>
+              <a:rPr lang="en-US" dirty="0"/>
+              <a:t>Carlo Teufel </a:t>
+            </a:r>
+          </a:p>
+          <a:p>
             <a:r>
               <a:rPr lang="en-US" i="1" dirty="0"/>
-              <a:t>(</a:t>
-            </a:r>
-            <a:r>
-              <a:rPr lang="en-US" i="1" dirty="0" err="1"/>
+              <a:t>Research Assistant</a:t>
+            </a:r>
+          </a:p>
+          <a:p>
+            <a:r>
+              <a:rPr lang="en-US" i="1" dirty="0"/>
+              <a:t>Email</a:t>
+            </a:r>
+            <a:r>
+              <a:rPr lang="en-US" dirty="0"/>
+              <a:t>: </a:t>
+            </a:r>
+            <a:r>
+              <a:rPr lang="en-US" dirty="0">
+                <a:hlinkClick r:id="rId3"/>
+              </a:rPr>
               <a:t>cteufel@ethz.ch</a:t>
             </a:r>
+            <a:endParaRPr lang="en-US" dirty="0"/>
+          </a:p>
+          <a:p>
             <a:r>
               <a:rPr lang="en-US" i="1" dirty="0"/>
-              <a:t>)</a:t>
+              <a:t>Phone</a:t>
+            </a:r>
+            <a:r>
+              <a:rPr lang="en-US" dirty="0"/>
+              <a:t>: +41 79 477 6068</a:t>
             </a:r>
           </a:p>
         </p:txBody>

</xml_diff>